<commit_message>
add more tests and enhancements
</commit_message>
<xml_diff>
--- a/touch-weights.pptx
+++ b/touch-weights.pptx
@@ -1,9 +1,12 @@
 
 <file path=ppt/presentation.xml><?xml version="1.0" encoding="utf-8"?>
-<p:presentation xmlns:a="http://schemas.openxmlformats.org/drawingml/2006/main" xmlns:p="http://schemas.openxmlformats.org/presentationml/2006/main" xmlns:r="http://schemas.openxmlformats.org/officeDocument/2006/relationships" saveSubsetFonts="1" autoCompressPictures="0">
+<p:presentation xmlns:a="http://schemas.openxmlformats.org/drawingml/2006/main" xmlns:r="http://schemas.openxmlformats.org/officeDocument/2006/relationships" xmlns:p="http://schemas.openxmlformats.org/presentationml/2006/main" saveSubsetFonts="1" autoCompressPictures="0">
   <p:sldMasterIdLst>
     <p:sldMasterId id="2147483648" r:id="rId1"/>
   </p:sldMasterIdLst>
+  <p:notesMasterIdLst>
+    <p:notesMasterId r:id="rId7"/>
+  </p:notesMasterIdLst>
   <p:sldIdLst>
     <p:sldId id="256" r:id="rId2"/>
     <p:sldId id="257" r:id="rId3"/>
@@ -11,8 +14,8 @@
     <p:sldId id="259" r:id="rId5"/>
     <p:sldId id="260" r:id="rId6"/>
   </p:sldIdLst>
-  <p:sldSz cx="12191695" cy="6858000"/>
-  <p:notesSz cx="6858000" cy="12191695"/>
+  <p:sldSz cx="12192000" cy="6858000"/>
+  <p:notesSz cx="6858000" cy="12192000"/>
   <p:defaultTextStyle>
     <a:lvl1pPr marL="0" algn="l" defTabSz="914400" rtl="0" eaLnBrk="1" latinLnBrk="0" hangingPunct="1">
       <a:defRPr sz="1800" kern="1200">
@@ -105,6 +108,11 @@
       </a:defRPr>
     </a:lvl9pPr>
   </p:defaultTextStyle>
+  <p:extLst>
+    <p:ext uri="{EFAFB233-063F-42B5-8137-9DF3F51BA10A}">
+      <p15:sldGuideLst xmlns:p15="http://schemas.microsoft.com/office/powerpoint/2012/main"/>
+    </p:ext>
+  </p:extLst>
 </p:presentation>
 </file>
 
@@ -130,234 +138,10 @@
           <a:chExt cx="0" cy="0"/>
         </a:xfrm>
       </p:grpSpPr>
-      <p:sp>
-        <p:nvSpPr>
-          <p:cNvPr id="2" name="Header Placeholder 1"/>
-          <p:cNvSpPr>
-            <a:spLocks noGrp="1"/>
-          </p:cNvSpPr>
-          <p:nvPr>
-            <p:ph type="hdr" sz="quarter"/>
-          </p:nvPr>
-        </p:nvSpPr>
-        <p:spPr>
-          <a:xfrm>
-            <a:off x="0" y="0"/>
-            <a:ext cx="2971800" cy="458788"/>
-          </a:xfrm>
-          <a:prstGeom prst="rect">
-            <a:avLst/>
-          </a:prstGeom>
-        </p:spPr>
-        <p:txBody>
-          <a:bodyPr vert="horz" lIns="91440" tIns="45720" rIns="91440" bIns="45720" rtlCol="0"/>
-          <a:lstStyle>
-            <a:lvl1pPr algn="l">
-              <a:defRPr sz="1200"/>
-            </a:lvl1pPr>
-          </a:lstStyle>
-          <a:p>
-            <a:endParaRPr lang="en-US"/>
-          </a:p>
-        </p:txBody>
-      </p:sp>
-      <p:sp>
-        <p:nvSpPr>
-          <p:cNvPr id="3" name="Date Placeholder 2"/>
-          <p:cNvSpPr>
-            <a:spLocks noGrp="1"/>
-          </p:cNvSpPr>
-          <p:nvPr>
-            <p:ph type="dt" idx="1"/>
-          </p:nvPr>
-        </p:nvSpPr>
-        <p:spPr>
-          <a:xfrm>
-            <a:off x="3884613" y="0"/>
-            <a:ext cx="2971800" cy="458788"/>
-          </a:xfrm>
-          <a:prstGeom prst="rect">
-            <a:avLst/>
-          </a:prstGeom>
-        </p:spPr>
-        <p:txBody>
-          <a:bodyPr vert="horz" lIns="91440" tIns="45720" rIns="91440" bIns="45720" rtlCol="0"/>
-          <a:lstStyle>
-            <a:lvl1pPr algn="r">
-              <a:defRPr sz="1200"/>
-            </a:lvl1pPr>
-          </a:lstStyle>
-          <a:p>
-            <a:fld id="{5282F153-3F37-0F45-9E97-73ACFA13230C}" type="datetimeFigureOut">
-              <a:rPr lang="en-US"/>
-              <a:t>7/23/19</a:t>
-            </a:fld>
-            <a:endParaRPr lang="en-US"/>
-          </a:p>
-        </p:txBody>
-      </p:sp>
-      <p:sp>
-        <p:nvSpPr>
-          <p:cNvPr id="4" name="Slide Image Placeholder 3"/>
-          <p:cNvSpPr>
-            <a:spLocks noGrp="1" noRot="1" noChangeAspect="1"/>
-          </p:cNvSpPr>
-          <p:nvPr>
-            <p:ph type="sldImg" idx="2"/>
-          </p:nvPr>
-        </p:nvSpPr>
-        <p:spPr>
-          <a:xfrm>
-            <a:off x="685800" y="1143000"/>
-            <a:ext cx="5486400" cy="3086100"/>
-          </a:xfrm>
-          <a:prstGeom prst="rect">
-            <a:avLst/>
-          </a:prstGeom>
-          <a:noFill/>
-          <a:ln w="12700">
-            <a:solidFill>
-              <a:prstClr val="black"/>
-            </a:solidFill>
-          </a:ln>
-        </p:spPr>
-        <p:txBody>
-          <a:bodyPr vert="horz" lIns="91440" tIns="45720" rIns="91440" bIns="45720" rtlCol="0" anchor="ctr"/>
-          <a:lstStyle/>
-          <a:p>
-            <a:endParaRPr lang="en-US"/>
-          </a:p>
-        </p:txBody>
-      </p:sp>
-      <p:sp>
-        <p:nvSpPr>
-          <p:cNvPr id="5" name="Notes Placeholder 4"/>
-          <p:cNvSpPr>
-            <a:spLocks noGrp="1"/>
-          </p:cNvSpPr>
-          <p:nvPr>
-            <p:ph type="body" sz="quarter" idx="3"/>
-          </p:nvPr>
-        </p:nvSpPr>
-        <p:spPr>
-          <a:xfrm>
-            <a:off x="685800" y="4400550"/>
-            <a:ext cx="5486400" cy="3600450"/>
-          </a:xfrm>
-          <a:prstGeom prst="rect">
-            <a:avLst/>
-          </a:prstGeom>
-        </p:spPr>
-        <p:txBody>
-          <a:bodyPr vert="horz" lIns="91440" tIns="45720" rIns="91440" bIns="45720" rtlCol="0"/>
-          <a:lstStyle/>
-          <a:p>
-            <a:pPr lvl="0"/>
-            <a:r>
-              <a:rPr lang="en-US"/>
-              <a:t>Click to edit Master text styles</a:t>
-            </a:r>
-          </a:p>
-          <a:p>
-            <a:pPr lvl="1"/>
-            <a:r>
-              <a:rPr lang="en-US"/>
-              <a:t>Second level</a:t>
-            </a:r>
-          </a:p>
-          <a:p>
-            <a:pPr lvl="2"/>
-            <a:r>
-              <a:rPr lang="en-US"/>
-              <a:t>Third level</a:t>
-            </a:r>
-          </a:p>
-          <a:p>
-            <a:pPr lvl="3"/>
-            <a:r>
-              <a:rPr lang="en-US"/>
-              <a:t>Fourth level</a:t>
-            </a:r>
-          </a:p>
-          <a:p>
-            <a:pPr lvl="4"/>
-            <a:r>
-              <a:rPr lang="en-US"/>
-              <a:t>Fifth level</a:t>
-            </a:r>
-          </a:p>
-        </p:txBody>
-      </p:sp>
-      <p:sp>
-        <p:nvSpPr>
-          <p:cNvPr id="6" name="Footer Placeholder 5"/>
-          <p:cNvSpPr>
-            <a:spLocks noGrp="1"/>
-          </p:cNvSpPr>
-          <p:nvPr>
-            <p:ph type="ftr" sz="quarter" idx="4"/>
-          </p:nvPr>
-        </p:nvSpPr>
-        <p:spPr>
-          <a:xfrm>
-            <a:off x="0" y="8685213"/>
-            <a:ext cx="2971800" cy="458787"/>
-          </a:xfrm>
-          <a:prstGeom prst="rect">
-            <a:avLst/>
-          </a:prstGeom>
-        </p:spPr>
-        <p:txBody>
-          <a:bodyPr vert="horz" lIns="91440" tIns="45720" rIns="91440" bIns="45720" rtlCol="0" anchor="b"/>
-          <a:lstStyle>
-            <a:lvl1pPr algn="l">
-              <a:defRPr sz="1200"/>
-            </a:lvl1pPr>
-          </a:lstStyle>
-          <a:p>
-            <a:endParaRPr lang="en-US"/>
-          </a:p>
-        </p:txBody>
-      </p:sp>
-      <p:sp>
-        <p:nvSpPr>
-          <p:cNvPr id="7" name="Slide Number Placeholder 6"/>
-          <p:cNvSpPr>
-            <a:spLocks noGrp="1"/>
-          </p:cNvSpPr>
-          <p:nvPr>
-            <p:ph type="sldNum" sz="quarter" idx="5"/>
-          </p:nvPr>
-        </p:nvSpPr>
-        <p:spPr>
-          <a:xfrm>
-            <a:off x="3884613" y="8685213"/>
-            <a:ext cx="2971800" cy="458787"/>
-          </a:xfrm>
-          <a:prstGeom prst="rect">
-            <a:avLst/>
-          </a:prstGeom>
-        </p:spPr>
-        <p:txBody>
-          <a:bodyPr vert="horz" lIns="91440" tIns="45720" rIns="91440" bIns="45720" rtlCol="0" anchor="b"/>
-          <a:lstStyle>
-            <a:lvl1pPr algn="r">
-              <a:defRPr sz="1200"/>
-            </a:lvl1pPr>
-          </a:lstStyle>
-          <a:p>
-            <a:fld id="{CE5E9CC1-C706-0F49-92D6-E571CC5EEA8F}" type="slidenum">
-              <a:rPr lang="en-US"/>
-              <a:t>‹#›</a:t>
-            </a:fld>
-            <a:endParaRPr lang="en-US"/>
-          </a:p>
-        </p:txBody>
-      </p:sp>
     </p:spTree>
     <p:extLst>
       <p:ext uri="{BB962C8B-B14F-4D97-AF65-F5344CB8AC3E}">
-        <p14:creationId xmlns:p14="http://schemas.microsoft.com/office/powerpoint/2010/main" val="1024086991"/>
+        <p14:creationId xmlns:p14="http://schemas.microsoft.com/office/powerpoint/2010/main" val="1444175372"/>
       </p:ext>
     </p:extLst>
   </p:cSld>
@@ -501,10 +285,6 @@
           <a:bodyPr/>
           <a:lstStyle/>
           <a:p>
-            <a:r>
-              <a:rPr lang="en-US" dirty="0"/>
-              <a:t/>
-            </a:r>
             <a:endParaRPr lang="en-US" dirty="0"/>
           </a:p>
         </p:txBody>
@@ -589,10 +369,6 @@
           <a:bodyPr/>
           <a:lstStyle/>
           <a:p>
-            <a:r>
-              <a:rPr lang="en-US" dirty="0"/>
-              <a:t/>
-            </a:r>
             <a:endParaRPr lang="en-US" dirty="0"/>
           </a:p>
         </p:txBody>
@@ -677,10 +453,6 @@
           <a:bodyPr/>
           <a:lstStyle/>
           <a:p>
-            <a:r>
-              <a:rPr lang="en-US" dirty="0"/>
-              <a:t/>
-            </a:r>
             <a:endParaRPr lang="en-US" dirty="0"/>
           </a:p>
         </p:txBody>
@@ -765,10 +537,6 @@
           <a:bodyPr/>
           <a:lstStyle/>
           <a:p>
-            <a:r>
-              <a:rPr lang="en-US" dirty="0"/>
-              <a:t/>
-            </a:r>
             <a:endParaRPr lang="en-US" dirty="0"/>
           </a:p>
         </p:txBody>
@@ -853,10 +621,6 @@
           <a:bodyPr/>
           <a:lstStyle/>
           <a:p>
-            <a:r>
-              <a:rPr lang="en-US" dirty="0"/>
-              <a:t/>
-            </a:r>
             <a:endParaRPr lang="en-US" dirty="0"/>
           </a:p>
         </p:txBody>
@@ -930,6 +694,11 @@
 <file path=ppt/slideMasters/slideMaster1.xml><?xml version="1.0" encoding="utf-8"?>
 <p:sldMaster xmlns:a="http://schemas.openxmlformats.org/drawingml/2006/main" xmlns:r="http://schemas.openxmlformats.org/officeDocument/2006/relationships" xmlns:p="http://schemas.openxmlformats.org/presentationml/2006/main">
   <p:cSld>
+    <p:bg>
+      <p:bgRef idx="1001">
+        <a:schemeClr val="bg1"/>
+      </p:bgRef>
+    </p:bg>
     <p:spTree>
       <p:nvGrpSpPr>
         <p:cNvPr id="1" name=""/>
@@ -1212,6 +981,7 @@
         <a:solidFill>
           <a:srgbClr val="1E2761"/>
         </a:solidFill>
+        <a:effectLst/>
       </p:bgPr>
     </p:bg>
     <p:spTree>
@@ -1247,6 +1017,13 @@
           </a:solidFill>
           <a:ln/>
         </p:spPr>
+        <p:txBody>
+          <a:bodyPr/>
+          <a:lstStyle/>
+          <a:p>
+            <a:endParaRPr lang="en-US"/>
+          </a:p>
+        </p:txBody>
       </p:sp>
       <p:sp>
         <p:nvSpPr>
@@ -1269,7 +1046,7 @@
           <a:bodyPr wrap="square" rtlCol="0" anchor="ctr"/>
           <a:lstStyle/>
           <a:p>
-            <a:pPr algn="ctr" indent="0" marL="0">
+            <a:pPr marL="0" indent="0" algn="ctr">
               <a:buNone/>
             </a:pPr>
             <a:r>
@@ -1308,7 +1085,7 @@
           <a:bodyPr wrap="square" rtlCol="0" anchor="ctr"/>
           <a:lstStyle/>
           <a:p>
-            <a:pPr algn="ctr" indent="0" marL="0">
+            <a:pPr marL="0" indent="0" algn="ctr">
               <a:buNone/>
             </a:pPr>
             <a:r>
@@ -1347,7 +1124,7 @@
           <a:bodyPr wrap="square" rtlCol="0" anchor="ctr"/>
           <a:lstStyle/>
           <a:p>
-            <a:pPr algn="ctr" indent="0" marL="0">
+            <a:pPr marL="0" indent="0" algn="ctr">
               <a:buNone/>
             </a:pPr>
             <a:r>
@@ -1386,7 +1163,7 @@
           <a:bodyPr wrap="square" rtlCol="0" anchor="ctr"/>
           <a:lstStyle/>
           <a:p>
-            <a:pPr algn="ctr" indent="0" marL="0">
+            <a:pPr marL="0" indent="0" algn="ctr">
               <a:buNone/>
             </a:pPr>
             <a:r>
@@ -1425,7 +1202,7 @@
           <a:bodyPr wrap="square" rtlCol="0" anchor="ctr"/>
           <a:lstStyle/>
           <a:p>
-            <a:pPr algn="ctr" indent="0" marL="0">
+            <a:pPr marL="0" indent="0" algn="ctr">
               <a:buNone/>
             </a:pPr>
             <a:r>
@@ -1446,7 +1223,7 @@
       <p:sp>
         <p:nvSpPr>
           <p:cNvPr id="8" name="Text 6">
-            <a:hlinkClick r:id="rId1" tooltip=""/>
+            <a:hlinkClick r:id="rId3"/>
           </p:cNvPr>
           <p:cNvSpPr/>
           <p:nvPr/>
@@ -1466,7 +1243,7 @@
           <a:bodyPr wrap="square" rtlCol="0" anchor="ctr"/>
           <a:lstStyle/>
           <a:p>
-            <a:pPr algn="ctr" indent="0" marL="0">
+            <a:pPr marL="0" indent="0" algn="ctr">
               <a:buNone/>
             </a:pPr>
             <a:r>
@@ -1477,7 +1254,7 @@
                 <a:latin typeface="Arial" pitchFamily="34" charset="0"/>
                 <a:ea typeface="Arial" pitchFamily="34" charset="-122"/>
                 <a:cs typeface="Arial" pitchFamily="34" charset="-120"/>
-                <a:hlinkClick r:id="rId1" invalidUrl="" action="" tgtFrame="" tooltip="" history="1" highlightClick="0" endSnd="0">
+                <a:hlinkClick r:id="rId3">
                   <a:extLst>
                     <a:ext uri="{A12FA001-AC4F-418D-AE19-62706E023703}">
                       <ahyp:hlinkClr xmlns:ahyp="http://schemas.microsoft.com/office/drawing/2018/hyperlinkcolor" val="tx"/>
@@ -1507,6 +1284,7 @@
         <a:solidFill>
           <a:srgbClr val="FFFFFF"/>
         </a:solidFill>
+        <a:effectLst/>
       </p:bgPr>
     </p:bg>
     <p:spTree>
@@ -1544,7 +1322,7 @@
           <a:bodyPr wrap="square" rtlCol="0" anchor="ctr"/>
           <a:lstStyle/>
           <a:p>
-            <a:pPr indent="0" marL="0">
+            <a:pPr marL="0" indent="0">
               <a:buNone/>
             </a:pPr>
             <a:r>
@@ -1583,7 +1361,7 @@
           <a:bodyPr wrap="square" rtlCol="0" anchor="ctr"/>
           <a:lstStyle/>
           <a:p>
-            <a:pPr indent="0" marL="0">
+            <a:pPr marL="0" indent="0">
               <a:buNone/>
             </a:pPr>
             <a:r>
@@ -1622,6 +1400,13 @@
           </a:solidFill>
           <a:ln/>
         </p:spPr>
+        <p:txBody>
+          <a:bodyPr/>
+          <a:lstStyle/>
+          <a:p>
+            <a:endParaRPr lang="en-US"/>
+          </a:p>
+        </p:txBody>
       </p:sp>
       <p:sp>
         <p:nvSpPr>
@@ -1644,7 +1429,7 @@
           <a:bodyPr wrap="square" rtlCol="0" anchor="ctr"/>
           <a:lstStyle/>
           <a:p>
-            <a:pPr indent="0" marL="0">
+            <a:pPr marL="0" indent="0">
               <a:buNone/>
             </a:pPr>
             <a:r>
@@ -1683,7 +1468,7 @@
           <a:bodyPr wrap="square" rtlCol="0" anchor="ctr"/>
           <a:lstStyle/>
           <a:p>
-            <a:pPr indent="0" marL="0">
+            <a:pPr marL="0" indent="0">
               <a:buNone/>
             </a:pPr>
             <a:r>
@@ -1722,6 +1507,13 @@
           </a:solidFill>
           <a:ln/>
         </p:spPr>
+        <p:txBody>
+          <a:bodyPr/>
+          <a:lstStyle/>
+          <a:p>
+            <a:endParaRPr lang="en-US"/>
+          </a:p>
+        </p:txBody>
       </p:sp>
       <p:sp>
         <p:nvSpPr>
@@ -1744,7 +1536,7 @@
           <a:bodyPr wrap="square" rtlCol="0" anchor="ctr"/>
           <a:lstStyle/>
           <a:p>
-            <a:pPr indent="0" marL="0">
+            <a:pPr marL="0" indent="0">
               <a:buNone/>
             </a:pPr>
             <a:r>
@@ -1783,7 +1575,7 @@
           <a:bodyPr wrap="square" rtlCol="0" anchor="ctr"/>
           <a:lstStyle/>
           <a:p>
-            <a:pPr indent="0" marL="0">
+            <a:pPr marL="0" indent="0">
               <a:buNone/>
             </a:pPr>
             <a:r>
@@ -1822,6 +1614,13 @@
           </a:solidFill>
           <a:ln/>
         </p:spPr>
+        <p:txBody>
+          <a:bodyPr/>
+          <a:lstStyle/>
+          <a:p>
+            <a:endParaRPr lang="en-US"/>
+          </a:p>
+        </p:txBody>
       </p:sp>
       <p:sp>
         <p:nvSpPr>
@@ -1844,7 +1643,7 @@
           <a:bodyPr wrap="square" rtlCol="0" anchor="ctr"/>
           <a:lstStyle/>
           <a:p>
-            <a:pPr indent="0" marL="0">
+            <a:pPr marL="0" indent="0">
               <a:buNone/>
             </a:pPr>
             <a:r>
@@ -1883,7 +1682,7 @@
           <a:bodyPr wrap="square" rtlCol="0" anchor="ctr"/>
           <a:lstStyle/>
           <a:p>
-            <a:pPr indent="0" marL="0">
+            <a:pPr marL="0" indent="0">
               <a:buNone/>
             </a:pPr>
             <a:r>
@@ -1922,6 +1721,13 @@
           </a:solidFill>
           <a:ln/>
         </p:spPr>
+        <p:txBody>
+          <a:bodyPr/>
+          <a:lstStyle/>
+          <a:p>
+            <a:endParaRPr lang="en-US"/>
+          </a:p>
+        </p:txBody>
       </p:sp>
       <p:sp>
         <p:nvSpPr>
@@ -1944,7 +1750,7 @@
           <a:bodyPr wrap="square" rtlCol="0" anchor="ctr"/>
           <a:lstStyle/>
           <a:p>
-            <a:pPr indent="0" marL="0">
+            <a:pPr marL="0" indent="0">
               <a:buNone/>
             </a:pPr>
             <a:r>
@@ -1983,7 +1789,7 @@
           <a:bodyPr wrap="square" rtlCol="0" anchor="ctr"/>
           <a:lstStyle/>
           <a:p>
-            <a:pPr indent="0" marL="0">
+            <a:pPr marL="0" indent="0">
               <a:buNone/>
             </a:pPr>
             <a:r>
@@ -2017,6 +1823,7 @@
         <a:solidFill>
           <a:srgbClr val="FFFFFF"/>
         </a:solidFill>
+        <a:effectLst/>
       </p:bgPr>
     </p:bg>
     <p:spTree>
@@ -2054,7 +1861,7 @@
           <a:bodyPr wrap="square" rtlCol="0" anchor="ctr"/>
           <a:lstStyle/>
           <a:p>
-            <a:pPr indent="0" marL="0">
+            <a:pPr marL="0" indent="0">
               <a:buNone/>
             </a:pPr>
             <a:r>
@@ -2093,7 +1900,7 @@
           <a:bodyPr wrap="square" rtlCol="0" anchor="ctr"/>
           <a:lstStyle/>
           <a:p>
-            <a:pPr indent="0" marL="0">
+            <a:pPr marL="0" indent="0">
               <a:buNone/>
             </a:pPr>
             <a:r>
@@ -2132,6 +1939,13 @@
           </a:solidFill>
           <a:ln/>
         </p:spPr>
+        <p:txBody>
+          <a:bodyPr/>
+          <a:lstStyle/>
+          <a:p>
+            <a:endParaRPr lang="en-US"/>
+          </a:p>
+        </p:txBody>
       </p:sp>
       <p:sp>
         <p:nvSpPr>
@@ -2154,7 +1968,7 @@
           <a:bodyPr wrap="square" rtlCol="0" anchor="ctr"/>
           <a:lstStyle/>
           <a:p>
-            <a:pPr algn="ctr" indent="0" marL="0">
+            <a:pPr marL="0" indent="0" algn="ctr">
               <a:buNone/>
             </a:pPr>
             <a:r>
@@ -2171,7 +1985,7 @@
             <a:endParaRPr lang="en-US" sz="1200" dirty="0"/>
           </a:p>
           <a:p>
-            <a:pPr algn="ctr" indent="0" marL="0">
+            <a:pPr marL="0" indent="0" algn="ctr">
               <a:buNone/>
             </a:pPr>
             <a:r>
@@ -2208,6 +2022,13 @@
           </a:solidFill>
           <a:ln/>
         </p:spPr>
+        <p:txBody>
+          <a:bodyPr/>
+          <a:lstStyle/>
+          <a:p>
+            <a:endParaRPr lang="en-US"/>
+          </a:p>
+        </p:txBody>
       </p:sp>
       <p:sp>
         <p:nvSpPr>
@@ -2230,6 +2051,13 @@
           </a:solidFill>
           <a:ln/>
         </p:spPr>
+        <p:txBody>
+          <a:bodyPr/>
+          <a:lstStyle/>
+          <a:p>
+            <a:endParaRPr lang="en-US"/>
+          </a:p>
+        </p:txBody>
       </p:sp>
       <p:sp>
         <p:nvSpPr>
@@ -2252,7 +2080,7 @@
           <a:bodyPr wrap="square" rtlCol="0" anchor="ctr"/>
           <a:lstStyle/>
           <a:p>
-            <a:pPr algn="ctr" indent="0" marL="0">
+            <a:pPr marL="0" indent="0" algn="ctr">
               <a:buNone/>
             </a:pPr>
             <a:r>
@@ -2269,7 +2097,7 @@
             <a:endParaRPr lang="en-US" sz="1200" dirty="0"/>
           </a:p>
           <a:p>
-            <a:pPr algn="ctr" indent="0" marL="0">
+            <a:pPr marL="0" indent="0" algn="ctr">
               <a:buNone/>
             </a:pPr>
             <a:r>
@@ -2306,6 +2134,13 @@
           </a:solidFill>
           <a:ln/>
         </p:spPr>
+        <p:txBody>
+          <a:bodyPr/>
+          <a:lstStyle/>
+          <a:p>
+            <a:endParaRPr lang="en-US"/>
+          </a:p>
+        </p:txBody>
       </p:sp>
       <p:sp>
         <p:nvSpPr>
@@ -2328,6 +2163,13 @@
           </a:solidFill>
           <a:ln/>
         </p:spPr>
+        <p:txBody>
+          <a:bodyPr/>
+          <a:lstStyle/>
+          <a:p>
+            <a:endParaRPr lang="en-US"/>
+          </a:p>
+        </p:txBody>
       </p:sp>
       <p:sp>
         <p:nvSpPr>
@@ -2350,7 +2192,7 @@
           <a:bodyPr wrap="square" rtlCol="0" anchor="ctr"/>
           <a:lstStyle/>
           <a:p>
-            <a:pPr algn="ctr" indent="0" marL="0">
+            <a:pPr marL="0" indent="0" algn="ctr">
               <a:buNone/>
             </a:pPr>
             <a:r>
@@ -2367,7 +2209,7 @@
             <a:endParaRPr lang="en-US" sz="1200" dirty="0"/>
           </a:p>
           <a:p>
-            <a:pPr algn="ctr" indent="0" marL="0">
+            <a:pPr marL="0" indent="0" algn="ctr">
               <a:buNone/>
             </a:pPr>
             <a:r>
@@ -2404,6 +2246,13 @@
           </a:solidFill>
           <a:ln/>
         </p:spPr>
+        <p:txBody>
+          <a:bodyPr/>
+          <a:lstStyle/>
+          <a:p>
+            <a:endParaRPr lang="en-US"/>
+          </a:p>
+        </p:txBody>
       </p:sp>
       <p:sp>
         <p:nvSpPr>
@@ -2426,6 +2275,13 @@
           </a:solidFill>
           <a:ln/>
         </p:spPr>
+        <p:txBody>
+          <a:bodyPr/>
+          <a:lstStyle/>
+          <a:p>
+            <a:endParaRPr lang="en-US"/>
+          </a:p>
+        </p:txBody>
       </p:sp>
       <p:sp>
         <p:nvSpPr>
@@ -2448,7 +2304,7 @@
           <a:bodyPr wrap="square" rtlCol="0" anchor="ctr"/>
           <a:lstStyle/>
           <a:p>
-            <a:pPr algn="ctr" indent="0" marL="0">
+            <a:pPr marL="0" indent="0" algn="ctr">
               <a:buNone/>
             </a:pPr>
             <a:r>
@@ -2465,7 +2321,7 @@
             <a:endParaRPr lang="en-US" sz="1200" dirty="0"/>
           </a:p>
           <a:p>
-            <a:pPr algn="ctr" indent="0" marL="0">
+            <a:pPr marL="0" indent="0" algn="ctr">
               <a:buNone/>
             </a:pPr>
             <a:r>
@@ -2502,6 +2358,13 @@
           </a:solidFill>
           <a:ln/>
         </p:spPr>
+        <p:txBody>
+          <a:bodyPr/>
+          <a:lstStyle/>
+          <a:p>
+            <a:endParaRPr lang="en-US"/>
+          </a:p>
+        </p:txBody>
       </p:sp>
       <p:sp>
         <p:nvSpPr>
@@ -2524,6 +2387,13 @@
           </a:solidFill>
           <a:ln/>
         </p:spPr>
+        <p:txBody>
+          <a:bodyPr/>
+          <a:lstStyle/>
+          <a:p>
+            <a:endParaRPr lang="en-US"/>
+          </a:p>
+        </p:txBody>
       </p:sp>
       <p:sp>
         <p:nvSpPr>
@@ -2546,7 +2416,7 @@
           <a:bodyPr wrap="square" rtlCol="0" anchor="ctr"/>
           <a:lstStyle/>
           <a:p>
-            <a:pPr algn="ctr" indent="0" marL="0">
+            <a:pPr marL="0" indent="0" algn="ctr">
               <a:buNone/>
             </a:pPr>
             <a:r>
@@ -2563,7 +2433,7 @@
             <a:endParaRPr lang="en-US" sz="1200" dirty="0"/>
           </a:p>
           <a:p>
-            <a:pPr algn="ctr" indent="0" marL="0">
+            <a:pPr marL="0" indent="0" algn="ctr">
               <a:buNone/>
             </a:pPr>
             <a:r>
@@ -2600,6 +2470,13 @@
           </a:solidFill>
           <a:ln/>
         </p:spPr>
+        <p:txBody>
+          <a:bodyPr/>
+          <a:lstStyle/>
+          <a:p>
+            <a:endParaRPr lang="en-US"/>
+          </a:p>
+        </p:txBody>
       </p:sp>
       <p:sp>
         <p:nvSpPr>
@@ -2622,6 +2499,13 @@
           </a:solidFill>
           <a:ln/>
         </p:spPr>
+        <p:txBody>
+          <a:bodyPr/>
+          <a:lstStyle/>
+          <a:p>
+            <a:endParaRPr lang="en-US"/>
+          </a:p>
+        </p:txBody>
       </p:sp>
       <p:sp>
         <p:nvSpPr>
@@ -2644,7 +2528,7 @@
           <a:bodyPr wrap="square" rtlCol="0" anchor="ctr"/>
           <a:lstStyle/>
           <a:p>
-            <a:pPr algn="ctr" indent="0" marL="0">
+            <a:pPr marL="0" indent="0" algn="ctr">
               <a:buNone/>
             </a:pPr>
             <a:r>
@@ -2661,7 +2545,7 @@
             <a:endParaRPr lang="en-US" sz="1200" dirty="0"/>
           </a:p>
           <a:p>
-            <a:pPr algn="ctr" indent="0" marL="0">
+            <a:pPr marL="0" indent="0" algn="ctr">
               <a:buNone/>
             </a:pPr>
             <a:r>
@@ -2698,6 +2582,13 @@
           </a:solidFill>
           <a:ln/>
         </p:spPr>
+        <p:txBody>
+          <a:bodyPr/>
+          <a:lstStyle/>
+          <a:p>
+            <a:endParaRPr lang="en-US"/>
+          </a:p>
+        </p:txBody>
       </p:sp>
       <p:sp>
         <p:nvSpPr>
@@ -2720,6 +2611,13 @@
           </a:solidFill>
           <a:ln/>
         </p:spPr>
+        <p:txBody>
+          <a:bodyPr/>
+          <a:lstStyle/>
+          <a:p>
+            <a:endParaRPr lang="en-US"/>
+          </a:p>
+        </p:txBody>
       </p:sp>
       <p:sp>
         <p:nvSpPr>
@@ -2742,7 +2640,7 @@
           <a:bodyPr wrap="square" rtlCol="0" anchor="ctr"/>
           <a:lstStyle/>
           <a:p>
-            <a:pPr algn="ctr" indent="0" marL="0">
+            <a:pPr marL="0" indent="0" algn="ctr">
               <a:buNone/>
             </a:pPr>
             <a:r>
@@ -2759,7 +2657,7 @@
             <a:endParaRPr lang="en-US" sz="1200" dirty="0"/>
           </a:p>
           <a:p>
-            <a:pPr algn="ctr" indent="0" marL="0">
+            <a:pPr marL="0" indent="0" algn="ctr">
               <a:buNone/>
             </a:pPr>
             <a:r>
@@ -2798,7 +2696,7 @@
           <a:bodyPr wrap="square" rtlCol="0" anchor="ctr"/>
           <a:lstStyle/>
           <a:p>
-            <a:pPr algn="ctr" indent="0" marL="0">
+            <a:pPr marL="0" indent="0" algn="ctr">
               <a:buNone/>
             </a:pPr>
             <a:r>
@@ -2835,6 +2733,13 @@
           </a:solidFill>
           <a:ln/>
         </p:spPr>
+        <p:txBody>
+          <a:bodyPr/>
+          <a:lstStyle/>
+          <a:p>
+            <a:endParaRPr lang="en-US"/>
+          </a:p>
+        </p:txBody>
       </p:sp>
       <p:sp>
         <p:nvSpPr>
@@ -2857,7 +2762,7 @@
           <a:bodyPr wrap="square" rtlCol="0" anchor="ctr"/>
           <a:lstStyle/>
           <a:p>
-            <a:pPr indent="0" marL="0">
+            <a:pPr marL="0" indent="0">
               <a:buNone/>
             </a:pPr>
             <a:r>
@@ -2896,7 +2801,7 @@
           <a:bodyPr wrap="square" rtlCol="0" anchor="ctr"/>
           <a:lstStyle/>
           <a:p>
-            <a:pPr indent="0" marL="0">
+            <a:pPr marL="0" indent="0">
               <a:buNone/>
             </a:pPr>
             <a:r>
@@ -2913,7 +2818,7 @@
             <a:endParaRPr lang="en-US" sz="1400" dirty="0"/>
           </a:p>
           <a:p>
-            <a:pPr indent="0" marL="0">
+            <a:pPr marL="0" indent="0">
               <a:buNone/>
             </a:pPr>
             <a:r>
@@ -2930,7 +2835,7 @@
             <a:endParaRPr lang="en-US" sz="1400" dirty="0"/>
           </a:p>
           <a:p>
-            <a:pPr indent="0" marL="0">
+            <a:pPr marL="0" indent="0">
               <a:buNone/>
             </a:pPr>
             <a:r>
@@ -2947,7 +2852,7 @@
             <a:endParaRPr lang="en-US" sz="1400" dirty="0"/>
           </a:p>
           <a:p>
-            <a:pPr indent="0" marL="0">
+            <a:pPr marL="0" indent="0">
               <a:buNone/>
             </a:pPr>
             <a:r>
@@ -2964,7 +2869,7 @@
             <a:endParaRPr lang="en-US" sz="1400" dirty="0"/>
           </a:p>
           <a:p>
-            <a:pPr indent="0" marL="0">
+            <a:pPr marL="0" indent="0">
               <a:buNone/>
             </a:pPr>
             <a:r>
@@ -2998,6 +2903,7 @@
         <a:solidFill>
           <a:srgbClr val="FFFFFF"/>
         </a:solidFill>
+        <a:effectLst/>
       </p:bgPr>
     </p:bg>
     <p:spTree>
@@ -3035,7 +2941,7 @@
           <a:bodyPr wrap="square" rtlCol="0" anchor="ctr"/>
           <a:lstStyle/>
           <a:p>
-            <a:pPr indent="0" marL="0">
+            <a:pPr marL="0" indent="0">
               <a:buNone/>
             </a:pPr>
             <a:r>
@@ -3074,7 +2980,7 @@
           <a:bodyPr wrap="square" rtlCol="0" anchor="ctr"/>
           <a:lstStyle/>
           <a:p>
-            <a:pPr indent="0" marL="0">
+            <a:pPr marL="0" indent="0">
               <a:buNone/>
             </a:pPr>
             <a:r>
@@ -3111,6 +3017,13 @@
           </a:solidFill>
           <a:ln/>
         </p:spPr>
+        <p:txBody>
+          <a:bodyPr/>
+          <a:lstStyle/>
+          <a:p>
+            <a:endParaRPr lang="en-US"/>
+          </a:p>
+        </p:txBody>
       </p:sp>
       <p:sp>
         <p:nvSpPr>
@@ -3133,7 +3046,7 @@
           <a:bodyPr wrap="square" rtlCol="0" anchor="ctr"/>
           <a:lstStyle/>
           <a:p>
-            <a:pPr algn="ctr" indent="0" marL="0">
+            <a:pPr marL="0" indent="0" algn="ctr">
               <a:buNone/>
             </a:pPr>
             <a:r>
@@ -3172,7 +3085,7 @@
           <a:bodyPr wrap="square" rtlCol="0" anchor="ctr"/>
           <a:lstStyle/>
           <a:p>
-            <a:pPr algn="ctr" indent="0" marL="0">
+            <a:pPr marL="0" indent="0" algn="ctr">
               <a:buNone/>
             </a:pPr>
             <a:r>
@@ -3184,175 +3097,10 @@
                 <a:ea typeface="Consolas" pitchFamily="34" charset="-122"/>
                 <a:cs typeface="Consolas" pitchFamily="34" charset="-120"/>
               </a:rPr>
-              <a:t>print(25*10)</a:t>
-            </a:r>
-            <a:endParaRPr lang="en-US" sz="1600" dirty="0"/>
-          </a:p>
-        </p:txBody>
-      </p:sp>
-      <p:sp>
-        <p:nvSpPr>
-          <p:cNvPr id="7" name="Text 5"/>
-          <p:cNvSpPr/>
-          <p:nvPr/>
-        </p:nvSpPr>
-        <p:spPr>
-          <a:xfrm>
-            <a:off x="594360" y="3200400"/>
-            <a:ext cx="3291840" cy="457200"/>
-          </a:xfrm>
-          <a:prstGeom prst="rect">
-            <a:avLst/>
-          </a:prstGeom>
-          <a:noFill/>
-          <a:ln/>
-        </p:spPr>
-        <p:txBody>
-          <a:bodyPr wrap="square" rtlCol="0" anchor="ctr"/>
-          <a:lstStyle/>
-          <a:p>
-            <a:pPr algn="ctr" indent="0" marL="0">
-              <a:buNone/>
-            </a:pPr>
-            <a:r>
-              <a:rPr lang="en-US" sz="1600" dirty="0">
-                <a:solidFill>
-                  <a:srgbClr val="FFFFFF"/>
-                </a:solidFill>
-                <a:latin typeface="Arial" pitchFamily="34" charset="0"/>
-                <a:ea typeface="Arial" pitchFamily="34" charset="-122"/>
-                <a:cs typeface="Arial" pitchFamily="34" charset="-120"/>
-              </a:rPr>
-              <a:t>Execution: 250</a:t>
-            </a:r>
-            <a:endParaRPr lang="en-US" sz="1600" dirty="0"/>
-          </a:p>
-        </p:txBody>
-      </p:sp>
-      <p:sp>
-        <p:nvSpPr>
-          <p:cNvPr id="8" name="Text 6"/>
-          <p:cNvSpPr/>
-          <p:nvPr/>
-        </p:nvSpPr>
-        <p:spPr>
-          <a:xfrm>
-            <a:off x="594360" y="3840480"/>
-            <a:ext cx="3291840" cy="457200"/>
-          </a:xfrm>
-          <a:prstGeom prst="rect">
-            <a:avLst/>
-          </a:prstGeom>
-          <a:noFill/>
-          <a:ln/>
-        </p:spPr>
-        <p:txBody>
-          <a:bodyPr wrap="square" rtlCol="0" anchor="ctr"/>
-          <a:lstStyle/>
-          <a:p>
-            <a:pPr algn="ctr" indent="0" marL="0">
-              <a:buNone/>
-            </a:pPr>
-            <a:r>
-              <a:rPr lang="en-US" sz="1800" b="1" dirty="0">
-                <a:solidFill>
-                  <a:srgbClr val="FFFFFF"/>
-                </a:solidFill>
-                <a:latin typeface="Arial" pitchFamily="34" charset="0"/>
-                <a:ea typeface="Arial" pitchFamily="34" charset="-122"/>
-                <a:cs typeface="Arial" pitchFamily="34" charset="-120"/>
-              </a:rPr>
-              <a:t>Reward: -1</a:t>
-            </a:r>
-            <a:endParaRPr lang="en-US" sz="1800" dirty="0"/>
-          </a:p>
-        </p:txBody>
-      </p:sp>
-      <p:sp>
-        <p:nvSpPr>
-          <p:cNvPr id="9" name="Shape 7"/>
-          <p:cNvSpPr/>
-          <p:nvPr/>
-        </p:nvSpPr>
-        <p:spPr>
-          <a:xfrm>
-            <a:off x="4297680" y="1554480"/>
-            <a:ext cx="3566160" cy="3657600"/>
-          </a:xfrm>
-          <a:prstGeom prst="rect">
-            <a:avLst/>
-          </a:prstGeom>
-          <a:solidFill>
-            <a:srgbClr val="1E2761"/>
-          </a:solidFill>
-          <a:ln/>
-        </p:spPr>
-      </p:sp>
-      <p:sp>
-        <p:nvSpPr>
-          <p:cNvPr id="10" name="Text 8"/>
-          <p:cNvSpPr/>
-          <p:nvPr/>
-        </p:nvSpPr>
-        <p:spPr>
-          <a:xfrm>
-            <a:off x="4297680" y="1691640"/>
-            <a:ext cx="3566160" cy="457200"/>
-          </a:xfrm>
-          <a:prstGeom prst="rect">
-            <a:avLst/>
-          </a:prstGeom>
-          <a:noFill/>
-          <a:ln/>
-        </p:spPr>
-        <p:txBody>
-          <a:bodyPr wrap="square" rtlCol="0" anchor="ctr"/>
-          <a:lstStyle/>
-          <a:p>
-            <a:pPr algn="ctr" indent="0" marL="0">
-              <a:buNone/>
-            </a:pPr>
-            <a:r>
-              <a:rPr lang="en-US" sz="2200" b="1" dirty="0">
-                <a:solidFill>
-                  <a:srgbClr val="FFFFFF"/>
-                </a:solidFill>
-                <a:latin typeface="Arial" pitchFamily="34" charset="0"/>
-                <a:ea typeface="Arial" pitchFamily="34" charset="-122"/>
-                <a:cs typeface="Arial" pitchFamily="34" charset="-120"/>
-              </a:rPr>
-              <a:t>TRAINING</a:t>
-            </a:r>
-            <a:endParaRPr lang="en-US" sz="2200" dirty="0"/>
-          </a:p>
-        </p:txBody>
-      </p:sp>
-      <p:sp>
-        <p:nvSpPr>
-          <p:cNvPr id="11" name="Text 9"/>
-          <p:cNvSpPr/>
-          <p:nvPr/>
-        </p:nvSpPr>
-        <p:spPr>
-          <a:xfrm>
-            <a:off x="4434840" y="2377440"/>
-            <a:ext cx="3291840" cy="640080"/>
-          </a:xfrm>
-          <a:prstGeom prst="rect">
-            <a:avLst/>
-          </a:prstGeom>
-          <a:noFill/>
-          <a:ln/>
-        </p:spPr>
-        <p:txBody>
-          <a:bodyPr wrap="square" rtlCol="0" anchor="ctr"/>
-          <a:lstStyle/>
-          <a:p>
-            <a:pPr algn="ctr" indent="0" marL="0">
-              <a:buNone/>
-            </a:pPr>
-            <a:r>
-              <a:rPr lang="en-US" sz="1600" dirty="0">
+              <a:t>print</a:t>
+            </a:r>
+            <a:r>
+              <a:rPr lang="en-US" sz="1600">
                 <a:solidFill>
                   <a:srgbClr val="FFFFFF"/>
                 </a:solidFill>
@@ -3360,173 +3108,8 @@
                 <a:ea typeface="Consolas" pitchFamily="34" charset="-122"/>
                 <a:cs typeface="Consolas" pitchFamily="34" charset="-120"/>
               </a:rPr>
-              <a:t>rollouts -&gt; execution</a:t>
-            </a:r>
-            <a:endParaRPr lang="en-US" sz="1600" dirty="0"/>
-          </a:p>
-        </p:txBody>
-      </p:sp>
-      <p:sp>
-        <p:nvSpPr>
-          <p:cNvPr id="12" name="Text 10"/>
-          <p:cNvSpPr/>
-          <p:nvPr/>
-        </p:nvSpPr>
-        <p:spPr>
-          <a:xfrm>
-            <a:off x="4434840" y="3200400"/>
-            <a:ext cx="3291840" cy="457200"/>
-          </a:xfrm>
-          <a:prstGeom prst="rect">
-            <a:avLst/>
-          </a:prstGeom>
-          <a:noFill/>
-          <a:ln/>
-        </p:spPr>
-        <p:txBody>
-          <a:bodyPr wrap="square" rtlCol="0" anchor="ctr"/>
-          <a:lstStyle/>
-          <a:p>
-            <a:pPr algn="ctr" indent="0" marL="0">
-              <a:buNone/>
-            </a:pPr>
-            <a:r>
-              <a:rPr lang="en-US" sz="1600" dirty="0">
-                <a:solidFill>
-                  <a:srgbClr val="FFFFFF"/>
-                </a:solidFill>
-                <a:latin typeface="Arial" pitchFamily="34" charset="0"/>
-                <a:ea typeface="Arial" pitchFamily="34" charset="-122"/>
-                <a:cs typeface="Arial" pitchFamily="34" charset="-120"/>
-              </a:rPr>
-              <a:t>reward -&gt; GRPO update</a:t>
-            </a:r>
-            <a:endParaRPr lang="en-US" sz="1600" dirty="0"/>
-          </a:p>
-        </p:txBody>
-      </p:sp>
-      <p:sp>
-        <p:nvSpPr>
-          <p:cNvPr id="13" name="Text 11"/>
-          <p:cNvSpPr/>
-          <p:nvPr/>
-        </p:nvSpPr>
-        <p:spPr>
-          <a:xfrm>
-            <a:off x="4434840" y="3840480"/>
-            <a:ext cx="3291840" cy="457200"/>
-          </a:xfrm>
-          <a:prstGeom prst="rect">
-            <a:avLst/>
-          </a:prstGeom>
-          <a:noFill/>
-          <a:ln/>
-        </p:spPr>
-        <p:txBody>
-          <a:bodyPr wrap="square" rtlCol="0" anchor="ctr"/>
-          <a:lstStyle/>
-          <a:p>
-            <a:pPr algn="ctr" indent="0" marL="0">
-              <a:buNone/>
-            </a:pPr>
-            <a:r>
-              <a:rPr lang="en-US" sz="1800" b="1" dirty="0">
-                <a:solidFill>
-                  <a:srgbClr val="FFFFFF"/>
-                </a:solidFill>
-                <a:latin typeface="Arial" pitchFamily="34" charset="0"/>
-                <a:ea typeface="Arial" pitchFamily="34" charset="-122"/>
-                <a:cs typeface="Arial" pitchFamily="34" charset="-120"/>
-              </a:rPr>
-              <a:t>LoRA adapter saved</a:t>
-            </a:r>
-            <a:endParaRPr lang="en-US" sz="1800" dirty="0"/>
-          </a:p>
-        </p:txBody>
-      </p:sp>
-      <p:sp>
-        <p:nvSpPr>
-          <p:cNvPr id="14" name="Shape 12"/>
-          <p:cNvSpPr/>
-          <p:nvPr/>
-        </p:nvSpPr>
-        <p:spPr>
-          <a:xfrm>
-            <a:off x="8138160" y="1554480"/>
-            <a:ext cx="3566160" cy="3657600"/>
-          </a:xfrm>
-          <a:prstGeom prst="rect">
-            <a:avLst/>
-          </a:prstGeom>
-          <a:solidFill>
-            <a:srgbClr val="2C5F2D"/>
-          </a:solidFill>
-          <a:ln/>
-        </p:spPr>
-      </p:sp>
-      <p:sp>
-        <p:nvSpPr>
-          <p:cNvPr id="15" name="Text 13"/>
-          <p:cNvSpPr/>
-          <p:nvPr/>
-        </p:nvSpPr>
-        <p:spPr>
-          <a:xfrm>
-            <a:off x="8138160" y="1691640"/>
-            <a:ext cx="3566160" cy="457200"/>
-          </a:xfrm>
-          <a:prstGeom prst="rect">
-            <a:avLst/>
-          </a:prstGeom>
-          <a:noFill/>
-          <a:ln/>
-        </p:spPr>
-        <p:txBody>
-          <a:bodyPr wrap="square" rtlCol="0" anchor="ctr"/>
-          <a:lstStyle/>
-          <a:p>
-            <a:pPr algn="ctr" indent="0" marL="0">
-              <a:buNone/>
-            </a:pPr>
-            <a:r>
-              <a:rPr lang="en-US" sz="2200" b="1" dirty="0">
-                <a:solidFill>
-                  <a:srgbClr val="FFFFFF"/>
-                </a:solidFill>
-                <a:latin typeface="Arial" pitchFamily="34" charset="0"/>
-                <a:ea typeface="Arial" pitchFamily="34" charset="-122"/>
-                <a:cs typeface="Arial" pitchFamily="34" charset="-120"/>
-              </a:rPr>
-              <a:t>AFTER</a:t>
-            </a:r>
-            <a:endParaRPr lang="en-US" sz="2200" dirty="0"/>
-          </a:p>
-        </p:txBody>
-      </p:sp>
-      <p:sp>
-        <p:nvSpPr>
-          <p:cNvPr id="16" name="Text 14"/>
-          <p:cNvSpPr/>
-          <p:nvPr/>
-        </p:nvSpPr>
-        <p:spPr>
-          <a:xfrm>
-            <a:off x="8275320" y="2377440"/>
-            <a:ext cx="3291840" cy="640080"/>
-          </a:xfrm>
-          <a:prstGeom prst="rect">
-            <a:avLst/>
-          </a:prstGeom>
-          <a:noFill/>
-          <a:ln/>
-        </p:spPr>
-        <p:txBody>
-          <a:bodyPr wrap="square" rtlCol="0" anchor="ctr"/>
-          <a:lstStyle/>
-          <a:p>
-            <a:pPr algn="ctr" indent="0" marL="0">
-              <a:buNone/>
-            </a:pPr>
+              <a:t>(25*1</a:t>
+            </a:r>
             <a:r>
               <a:rPr lang="en-US" sz="1600" dirty="0">
                 <a:solidFill>
@@ -3536,6 +3119,383 @@
                 <a:ea typeface="Consolas" pitchFamily="34" charset="-122"/>
                 <a:cs typeface="Consolas" pitchFamily="34" charset="-120"/>
               </a:rPr>
+              <a:t>0</a:t>
+            </a:r>
+            <a:r>
+              <a:rPr lang="en-US" sz="1600">
+                <a:solidFill>
+                  <a:srgbClr val="FFFFFF"/>
+                </a:solidFill>
+                <a:latin typeface="Consolas" pitchFamily="34" charset="0"/>
+                <a:ea typeface="Consolas" pitchFamily="34" charset="-122"/>
+                <a:cs typeface="Consolas" pitchFamily="34" charset="-120"/>
+              </a:rPr>
+              <a:t>)</a:t>
+            </a:r>
+            <a:endParaRPr lang="en-US" sz="1600" dirty="0"/>
+          </a:p>
+        </p:txBody>
+      </p:sp>
+      <p:sp>
+        <p:nvSpPr>
+          <p:cNvPr id="7" name="Text 5"/>
+          <p:cNvSpPr/>
+          <p:nvPr/>
+        </p:nvSpPr>
+        <p:spPr>
+          <a:xfrm>
+            <a:off x="594360" y="3200400"/>
+            <a:ext cx="3291840" cy="457200"/>
+          </a:xfrm>
+          <a:prstGeom prst="rect">
+            <a:avLst/>
+          </a:prstGeom>
+          <a:noFill/>
+          <a:ln/>
+        </p:spPr>
+        <p:txBody>
+          <a:bodyPr wrap="square" rtlCol="0" anchor="ctr"/>
+          <a:lstStyle/>
+          <a:p>
+            <a:pPr marL="0" indent="0" algn="ctr">
+              <a:buNone/>
+            </a:pPr>
+            <a:r>
+              <a:rPr lang="en-US" sz="1600" dirty="0">
+                <a:solidFill>
+                  <a:srgbClr val="FFFFFF"/>
+                </a:solidFill>
+                <a:latin typeface="Arial" pitchFamily="34" charset="0"/>
+                <a:ea typeface="Arial" pitchFamily="34" charset="-122"/>
+                <a:cs typeface="Arial" pitchFamily="34" charset="-120"/>
+              </a:rPr>
+              <a:t>Execution: 250</a:t>
+            </a:r>
+            <a:endParaRPr lang="en-US" sz="1600" dirty="0"/>
+          </a:p>
+        </p:txBody>
+      </p:sp>
+      <p:sp>
+        <p:nvSpPr>
+          <p:cNvPr id="8" name="Text 6"/>
+          <p:cNvSpPr/>
+          <p:nvPr/>
+        </p:nvSpPr>
+        <p:spPr>
+          <a:xfrm>
+            <a:off x="594360" y="3840480"/>
+            <a:ext cx="3291840" cy="457200"/>
+          </a:xfrm>
+          <a:prstGeom prst="rect">
+            <a:avLst/>
+          </a:prstGeom>
+          <a:noFill/>
+          <a:ln/>
+        </p:spPr>
+        <p:txBody>
+          <a:bodyPr wrap="square" rtlCol="0" anchor="ctr"/>
+          <a:lstStyle/>
+          <a:p>
+            <a:pPr marL="0" indent="0" algn="ctr">
+              <a:buNone/>
+            </a:pPr>
+            <a:r>
+              <a:rPr lang="en-US" sz="1800" b="1" dirty="0">
+                <a:solidFill>
+                  <a:srgbClr val="FFFFFF"/>
+                </a:solidFill>
+                <a:latin typeface="Arial" pitchFamily="34" charset="0"/>
+                <a:ea typeface="Arial" pitchFamily="34" charset="-122"/>
+                <a:cs typeface="Arial" pitchFamily="34" charset="-120"/>
+              </a:rPr>
+              <a:t>Reward: -1</a:t>
+            </a:r>
+            <a:endParaRPr lang="en-US" sz="1800" dirty="0"/>
+          </a:p>
+        </p:txBody>
+      </p:sp>
+      <p:sp>
+        <p:nvSpPr>
+          <p:cNvPr id="9" name="Shape 7"/>
+          <p:cNvSpPr/>
+          <p:nvPr/>
+        </p:nvSpPr>
+        <p:spPr>
+          <a:xfrm>
+            <a:off x="4297680" y="1554480"/>
+            <a:ext cx="3566160" cy="3657600"/>
+          </a:xfrm>
+          <a:prstGeom prst="rect">
+            <a:avLst/>
+          </a:prstGeom>
+          <a:solidFill>
+            <a:srgbClr val="1E2761"/>
+          </a:solidFill>
+          <a:ln/>
+        </p:spPr>
+        <p:txBody>
+          <a:bodyPr/>
+          <a:lstStyle/>
+          <a:p>
+            <a:endParaRPr lang="en-US"/>
+          </a:p>
+        </p:txBody>
+      </p:sp>
+      <p:sp>
+        <p:nvSpPr>
+          <p:cNvPr id="10" name="Text 8"/>
+          <p:cNvSpPr/>
+          <p:nvPr/>
+        </p:nvSpPr>
+        <p:spPr>
+          <a:xfrm>
+            <a:off x="4297680" y="1691640"/>
+            <a:ext cx="3566160" cy="457200"/>
+          </a:xfrm>
+          <a:prstGeom prst="rect">
+            <a:avLst/>
+          </a:prstGeom>
+          <a:noFill/>
+          <a:ln/>
+        </p:spPr>
+        <p:txBody>
+          <a:bodyPr wrap="square" rtlCol="0" anchor="ctr"/>
+          <a:lstStyle/>
+          <a:p>
+            <a:pPr marL="0" indent="0" algn="ctr">
+              <a:buNone/>
+            </a:pPr>
+            <a:r>
+              <a:rPr lang="en-US" sz="2200" b="1" dirty="0">
+                <a:solidFill>
+                  <a:srgbClr val="FFFFFF"/>
+                </a:solidFill>
+                <a:latin typeface="Arial" pitchFamily="34" charset="0"/>
+                <a:ea typeface="Arial" pitchFamily="34" charset="-122"/>
+                <a:cs typeface="Arial" pitchFamily="34" charset="-120"/>
+              </a:rPr>
+              <a:t>TRAINING</a:t>
+            </a:r>
+            <a:endParaRPr lang="en-US" sz="2200" dirty="0"/>
+          </a:p>
+        </p:txBody>
+      </p:sp>
+      <p:sp>
+        <p:nvSpPr>
+          <p:cNvPr id="11" name="Text 9"/>
+          <p:cNvSpPr/>
+          <p:nvPr/>
+        </p:nvSpPr>
+        <p:spPr>
+          <a:xfrm>
+            <a:off x="4434840" y="2377440"/>
+            <a:ext cx="3291840" cy="640080"/>
+          </a:xfrm>
+          <a:prstGeom prst="rect">
+            <a:avLst/>
+          </a:prstGeom>
+          <a:noFill/>
+          <a:ln/>
+        </p:spPr>
+        <p:txBody>
+          <a:bodyPr wrap="square" rtlCol="0" anchor="ctr"/>
+          <a:lstStyle/>
+          <a:p>
+            <a:pPr marL="0" indent="0" algn="ctr">
+              <a:buNone/>
+            </a:pPr>
+            <a:r>
+              <a:rPr lang="en-US" sz="1600" dirty="0">
+                <a:solidFill>
+                  <a:srgbClr val="FFFFFF"/>
+                </a:solidFill>
+                <a:latin typeface="Consolas" pitchFamily="34" charset="0"/>
+                <a:ea typeface="Consolas" pitchFamily="34" charset="-122"/>
+                <a:cs typeface="Consolas" pitchFamily="34" charset="-120"/>
+              </a:rPr>
+              <a:t>rollouts -&gt; execution</a:t>
+            </a:r>
+            <a:endParaRPr lang="en-US" sz="1600" dirty="0"/>
+          </a:p>
+        </p:txBody>
+      </p:sp>
+      <p:sp>
+        <p:nvSpPr>
+          <p:cNvPr id="12" name="Text 10"/>
+          <p:cNvSpPr/>
+          <p:nvPr/>
+        </p:nvSpPr>
+        <p:spPr>
+          <a:xfrm>
+            <a:off x="4434840" y="3200400"/>
+            <a:ext cx="3291840" cy="457200"/>
+          </a:xfrm>
+          <a:prstGeom prst="rect">
+            <a:avLst/>
+          </a:prstGeom>
+          <a:noFill/>
+          <a:ln/>
+        </p:spPr>
+        <p:txBody>
+          <a:bodyPr wrap="square" rtlCol="0" anchor="ctr"/>
+          <a:lstStyle/>
+          <a:p>
+            <a:pPr marL="0" indent="0" algn="ctr">
+              <a:buNone/>
+            </a:pPr>
+            <a:r>
+              <a:rPr lang="en-US" sz="1600" dirty="0">
+                <a:solidFill>
+                  <a:srgbClr val="FFFFFF"/>
+                </a:solidFill>
+                <a:latin typeface="Arial" pitchFamily="34" charset="0"/>
+                <a:ea typeface="Arial" pitchFamily="34" charset="-122"/>
+                <a:cs typeface="Arial" pitchFamily="34" charset="-120"/>
+              </a:rPr>
+              <a:t>reward -&gt; GRPO update</a:t>
+            </a:r>
+            <a:endParaRPr lang="en-US" sz="1600" dirty="0"/>
+          </a:p>
+        </p:txBody>
+      </p:sp>
+      <p:sp>
+        <p:nvSpPr>
+          <p:cNvPr id="13" name="Text 11"/>
+          <p:cNvSpPr/>
+          <p:nvPr/>
+        </p:nvSpPr>
+        <p:spPr>
+          <a:xfrm>
+            <a:off x="4434840" y="3840480"/>
+            <a:ext cx="3291840" cy="457200"/>
+          </a:xfrm>
+          <a:prstGeom prst="rect">
+            <a:avLst/>
+          </a:prstGeom>
+          <a:noFill/>
+          <a:ln/>
+        </p:spPr>
+        <p:txBody>
+          <a:bodyPr wrap="square" rtlCol="0" anchor="ctr"/>
+          <a:lstStyle/>
+          <a:p>
+            <a:pPr marL="0" indent="0" algn="ctr">
+              <a:buNone/>
+            </a:pPr>
+            <a:r>
+              <a:rPr lang="en-US" sz="1800" b="1" dirty="0">
+                <a:solidFill>
+                  <a:srgbClr val="FFFFFF"/>
+                </a:solidFill>
+                <a:latin typeface="Arial" pitchFamily="34" charset="0"/>
+                <a:ea typeface="Arial" pitchFamily="34" charset="-122"/>
+                <a:cs typeface="Arial" pitchFamily="34" charset="-120"/>
+              </a:rPr>
+              <a:t>LoRA adapter saved</a:t>
+            </a:r>
+            <a:endParaRPr lang="en-US" sz="1800" dirty="0"/>
+          </a:p>
+        </p:txBody>
+      </p:sp>
+      <p:sp>
+        <p:nvSpPr>
+          <p:cNvPr id="14" name="Shape 12"/>
+          <p:cNvSpPr/>
+          <p:nvPr/>
+        </p:nvSpPr>
+        <p:spPr>
+          <a:xfrm>
+            <a:off x="8138160" y="1554480"/>
+            <a:ext cx="3566160" cy="3657600"/>
+          </a:xfrm>
+          <a:prstGeom prst="rect">
+            <a:avLst/>
+          </a:prstGeom>
+          <a:solidFill>
+            <a:srgbClr val="2C5F2D"/>
+          </a:solidFill>
+          <a:ln/>
+        </p:spPr>
+        <p:txBody>
+          <a:bodyPr/>
+          <a:lstStyle/>
+          <a:p>
+            <a:endParaRPr lang="en-US"/>
+          </a:p>
+        </p:txBody>
+      </p:sp>
+      <p:sp>
+        <p:nvSpPr>
+          <p:cNvPr id="15" name="Text 13"/>
+          <p:cNvSpPr/>
+          <p:nvPr/>
+        </p:nvSpPr>
+        <p:spPr>
+          <a:xfrm>
+            <a:off x="8138160" y="1691640"/>
+            <a:ext cx="3566160" cy="457200"/>
+          </a:xfrm>
+          <a:prstGeom prst="rect">
+            <a:avLst/>
+          </a:prstGeom>
+          <a:noFill/>
+          <a:ln/>
+        </p:spPr>
+        <p:txBody>
+          <a:bodyPr wrap="square" rtlCol="0" anchor="ctr"/>
+          <a:lstStyle/>
+          <a:p>
+            <a:pPr marL="0" indent="0" algn="ctr">
+              <a:buNone/>
+            </a:pPr>
+            <a:r>
+              <a:rPr lang="en-US" sz="2200" b="1" dirty="0">
+                <a:solidFill>
+                  <a:srgbClr val="FFFFFF"/>
+                </a:solidFill>
+                <a:latin typeface="Arial" pitchFamily="34" charset="0"/>
+                <a:ea typeface="Arial" pitchFamily="34" charset="-122"/>
+                <a:cs typeface="Arial" pitchFamily="34" charset="-120"/>
+              </a:rPr>
+              <a:t>AFTER</a:t>
+            </a:r>
+            <a:endParaRPr lang="en-US" sz="2200" dirty="0"/>
+          </a:p>
+        </p:txBody>
+      </p:sp>
+      <p:sp>
+        <p:nvSpPr>
+          <p:cNvPr id="16" name="Text 14"/>
+          <p:cNvSpPr/>
+          <p:nvPr/>
+        </p:nvSpPr>
+        <p:spPr>
+          <a:xfrm>
+            <a:off x="8275320" y="2377440"/>
+            <a:ext cx="3291840" cy="640080"/>
+          </a:xfrm>
+          <a:prstGeom prst="rect">
+            <a:avLst/>
+          </a:prstGeom>
+          <a:noFill/>
+          <a:ln/>
+        </p:spPr>
+        <p:txBody>
+          <a:bodyPr wrap="square" rtlCol="0" anchor="ctr"/>
+          <a:lstStyle/>
+          <a:p>
+            <a:pPr marL="0" indent="0" algn="ctr">
+              <a:buNone/>
+            </a:pPr>
+            <a:r>
+              <a:rPr lang="en-US" sz="1600" dirty="0">
+                <a:solidFill>
+                  <a:srgbClr val="FFFFFF"/>
+                </a:solidFill>
+                <a:latin typeface="Consolas" pitchFamily="34" charset="0"/>
+                <a:ea typeface="Consolas" pitchFamily="34" charset="-122"/>
+                <a:cs typeface="Consolas" pitchFamily="34" charset="-120"/>
+              </a:rPr>
               <a:t>print(25*12)</a:t>
             </a:r>
             <a:endParaRPr lang="en-US" sz="1600" dirty="0"/>
@@ -3563,7 +3523,7 @@
           <a:bodyPr wrap="square" rtlCol="0" anchor="ctr"/>
           <a:lstStyle/>
           <a:p>
-            <a:pPr algn="ctr" indent="0" marL="0">
+            <a:pPr marL="0" indent="0" algn="ctr">
               <a:buNone/>
             </a:pPr>
             <a:r>
@@ -3602,7 +3562,7 @@
           <a:bodyPr wrap="square" rtlCol="0" anchor="ctr"/>
           <a:lstStyle/>
           <a:p>
-            <a:pPr algn="ctr" indent="0" marL="0">
+            <a:pPr marL="0" indent="0" algn="ctr">
               <a:buNone/>
             </a:pPr>
             <a:r>
@@ -3641,7 +3601,7 @@
           <a:bodyPr wrap="square" rtlCol="0" anchor="ctr"/>
           <a:lstStyle/>
           <a:p>
-            <a:pPr algn="ctr" indent="0" marL="0">
+            <a:pPr marL="0" indent="0" algn="ctr">
               <a:buNone/>
             </a:pPr>
             <a:r>
@@ -3675,6 +3635,7 @@
         <a:solidFill>
           <a:srgbClr val="1E2761"/>
         </a:solidFill>
+        <a:effectLst/>
       </p:bgPr>
     </p:bg>
     <p:spTree>
@@ -3710,6 +3671,13 @@
           </a:solidFill>
           <a:ln/>
         </p:spPr>
+        <p:txBody>
+          <a:bodyPr/>
+          <a:lstStyle/>
+          <a:p>
+            <a:endParaRPr lang="en-US"/>
+          </a:p>
+        </p:txBody>
       </p:sp>
       <p:sp>
         <p:nvSpPr>
@@ -3732,7 +3700,7 @@
           <a:bodyPr wrap="square" rtlCol="0" anchor="ctr"/>
           <a:lstStyle/>
           <a:p>
-            <a:pPr algn="ctr" indent="0" marL="0">
+            <a:pPr marL="0" indent="0" algn="ctr">
               <a:buNone/>
             </a:pPr>
             <a:r>
@@ -3771,7 +3739,7 @@
           <a:bodyPr wrap="square" rtlCol="0" anchor="ctr"/>
           <a:lstStyle/>
           <a:p>
-            <a:pPr algn="ctr" indent="0" marL="0">
+            <a:pPr marL="0" indent="0" algn="ctr">
               <a:buNone/>
             </a:pPr>
             <a:r>
@@ -3810,7 +3778,7 @@
           <a:bodyPr wrap="square" rtlCol="0" anchor="ctr"/>
           <a:lstStyle/>
           <a:p>
-            <a:pPr algn="ctr" indent="0" marL="0">
+            <a:pPr marL="0" indent="0" algn="ctr">
               <a:buNone/>
             </a:pPr>
             <a:r>
@@ -3831,7 +3799,7 @@
       <p:sp>
         <p:nvSpPr>
           <p:cNvPr id="6" name="Text 4">
-            <a:hlinkClick r:id="rId1" tooltip=""/>
+            <a:hlinkClick r:id="rId3"/>
           </p:cNvPr>
           <p:cNvSpPr/>
           <p:nvPr/>
@@ -3851,7 +3819,7 @@
           <a:bodyPr wrap="square" rtlCol="0" anchor="ctr"/>
           <a:lstStyle/>
           <a:p>
-            <a:pPr algn="ctr" indent="0" marL="0">
+            <a:pPr marL="0" indent="0" algn="ctr">
               <a:buNone/>
             </a:pPr>
             <a:r>
@@ -3862,7 +3830,7 @@
                 <a:latin typeface="Arial" pitchFamily="34" charset="0"/>
                 <a:ea typeface="Arial" pitchFamily="34" charset="-122"/>
                 <a:cs typeface="Arial" pitchFamily="34" charset="-120"/>
-                <a:hlinkClick r:id="rId1" invalidUrl="" action="" tgtFrame="" tooltip="" history="1" highlightClick="0" endSnd="0">
+                <a:hlinkClick r:id="rId3">
                   <a:extLst>
                     <a:ext uri="{A12FA001-AC4F-418D-AE19-62706E023703}">
                       <ahyp:hlinkClr xmlns:ahyp="http://schemas.microsoft.com/office/drawing/2018/hyperlinkcolor" val="tx"/>
@@ -4177,4 +4145,319 @@
     </a:ext>
   </a:extLst>
 </a:theme>
+</file>
+
+<file path=ppt/theme/theme2.xml><?xml version="1.0" encoding="utf-8"?>
+<a:theme xmlns:a="http://schemas.openxmlformats.org/drawingml/2006/main" name="Office Theme">
+  <a:themeElements>
+    <a:clrScheme name="Office">
+      <a:dk1>
+        <a:sysClr val="windowText" lastClr="000000"/>
+      </a:dk1>
+      <a:lt1>
+        <a:sysClr val="window" lastClr="FFFFFF"/>
+      </a:lt1>
+      <a:dk2>
+        <a:srgbClr val="0E2841"/>
+      </a:dk2>
+      <a:lt2>
+        <a:srgbClr val="E8E8E8"/>
+      </a:lt2>
+      <a:accent1>
+        <a:srgbClr val="156082"/>
+      </a:accent1>
+      <a:accent2>
+        <a:srgbClr val="E97132"/>
+      </a:accent2>
+      <a:accent3>
+        <a:srgbClr val="196B24"/>
+      </a:accent3>
+      <a:accent4>
+        <a:srgbClr val="0F9ED5"/>
+      </a:accent4>
+      <a:accent5>
+        <a:srgbClr val="A02B93"/>
+      </a:accent5>
+      <a:accent6>
+        <a:srgbClr val="4EA72E"/>
+      </a:accent6>
+      <a:hlink>
+        <a:srgbClr val="467886"/>
+      </a:hlink>
+      <a:folHlink>
+        <a:srgbClr val="96607D"/>
+      </a:folHlink>
+    </a:clrScheme>
+    <a:fontScheme name="Office">
+      <a:majorFont>
+        <a:latin typeface="Aptos Display" panose="02110004020202020204"/>
+        <a:ea typeface=""/>
+        <a:cs typeface=""/>
+        <a:font script="Jpan" typeface="游ゴシック Light"/>
+        <a:font script="Hang" typeface="맑은 고딕"/>
+        <a:font script="Hans" typeface="等线 Light"/>
+        <a:font script="Hant" typeface="新細明體"/>
+        <a:font script="Arab" typeface="Times New Roman"/>
+        <a:font script="Hebr" typeface="Times New Roman"/>
+        <a:font script="Thai" typeface="Angsana New"/>
+        <a:font script="Ethi" typeface="Nyala"/>
+        <a:font script="Beng" typeface="Vrinda"/>
+        <a:font script="Gujr" typeface="Shruti"/>
+        <a:font script="Khmr" typeface="MoolBoran"/>
+        <a:font script="Knda" typeface="Tunga"/>
+        <a:font script="Guru" typeface="Raavi"/>
+        <a:font script="Cans" typeface="Euphemia"/>
+        <a:font script="Cher" typeface="Plantagenet Cherokee"/>
+        <a:font script="Yiii" typeface="Microsoft Yi Baiti"/>
+        <a:font script="Tibt" typeface="Microsoft Himalaya"/>
+        <a:font script="Thaa" typeface="MV Boli"/>
+        <a:font script="Deva" typeface="Mangal"/>
+        <a:font script="Telu" typeface="Gautami"/>
+        <a:font script="Taml" typeface="Latha"/>
+        <a:font script="Syrc" typeface="Estrangelo Edessa"/>
+        <a:font script="Orya" typeface="Kalinga"/>
+        <a:font script="Mlym" typeface="Kartika"/>
+        <a:font script="Laoo" typeface="DokChampa"/>
+        <a:font script="Sinh" typeface="Iskoola Pota"/>
+        <a:font script="Mong" typeface="Mongolian Baiti"/>
+        <a:font script="Viet" typeface="Times New Roman"/>
+        <a:font script="Uigh" typeface="Microsoft Uighur"/>
+        <a:font script="Geor" typeface="Sylfaen"/>
+        <a:font script="Armn" typeface="Arial"/>
+        <a:font script="Bugi" typeface="Leelawadee UI"/>
+        <a:font script="Bopo" typeface="Microsoft JhengHei"/>
+        <a:font script="Java" typeface="Javanese Text"/>
+        <a:font script="Lisu" typeface="Segoe UI"/>
+        <a:font script="Mymr" typeface="Myanmar Text"/>
+        <a:font script="Nkoo" typeface="Ebrima"/>
+        <a:font script="Olck" typeface="Nirmala UI"/>
+        <a:font script="Osma" typeface="Ebrima"/>
+        <a:font script="Phag" typeface="Phagspa"/>
+        <a:font script="Syrn" typeface="Estrangelo Edessa"/>
+        <a:font script="Syrj" typeface="Estrangelo Edessa"/>
+        <a:font script="Syre" typeface="Estrangelo Edessa"/>
+        <a:font script="Sora" typeface="Nirmala UI"/>
+        <a:font script="Tale" typeface="Microsoft Tai Le"/>
+        <a:font script="Talu" typeface="Microsoft New Tai Lue"/>
+        <a:font script="Tfng" typeface="Ebrima"/>
+      </a:majorFont>
+      <a:minorFont>
+        <a:latin typeface="Aptos" panose="02110004020202020204"/>
+        <a:ea typeface=""/>
+        <a:cs typeface=""/>
+        <a:font script="Jpan" typeface="游ゴシック"/>
+        <a:font script="Hang" typeface="맑은 고딕"/>
+        <a:font script="Hans" typeface="等线"/>
+        <a:font script="Hant" typeface="新細明體"/>
+        <a:font script="Arab" typeface="Arial"/>
+        <a:font script="Hebr" typeface="Arial"/>
+        <a:font script="Thai" typeface="Cordia New"/>
+        <a:font script="Ethi" typeface="Nyala"/>
+        <a:font script="Beng" typeface="Vrinda"/>
+        <a:font script="Gujr" typeface="Shruti"/>
+        <a:font script="Khmr" typeface="DaunPenh"/>
+        <a:font script="Knda" typeface="Tunga"/>
+        <a:font script="Guru" typeface="Raavi"/>
+        <a:font script="Cans" typeface="Euphemia"/>
+        <a:font script="Cher" typeface="Plantagenet Cherokee"/>
+        <a:font script="Yiii" typeface="Microsoft Yi Baiti"/>
+        <a:font script="Tibt" typeface="Microsoft Himalaya"/>
+        <a:font script="Thaa" typeface="MV Boli"/>
+        <a:font script="Deva" typeface="Mangal"/>
+        <a:font script="Telu" typeface="Gautami"/>
+        <a:font script="Taml" typeface="Latha"/>
+        <a:font script="Syrc" typeface="Estrangelo Edessa"/>
+        <a:font script="Orya" typeface="Kalinga"/>
+        <a:font script="Mlym" typeface="Kartika"/>
+        <a:font script="Laoo" typeface="DokChampa"/>
+        <a:font script="Sinh" typeface="Iskoola Pota"/>
+        <a:font script="Mong" typeface="Mongolian Baiti"/>
+        <a:font script="Viet" typeface="Arial"/>
+        <a:font script="Uigh" typeface="Microsoft Uighur"/>
+        <a:font script="Geor" typeface="Sylfaen"/>
+        <a:font script="Armn" typeface="Arial"/>
+        <a:font script="Bugi" typeface="Leelawadee UI"/>
+        <a:font script="Bopo" typeface="Microsoft JhengHei"/>
+        <a:font script="Java" typeface="Javanese Text"/>
+        <a:font script="Lisu" typeface="Segoe UI"/>
+        <a:font script="Mymr" typeface="Myanmar Text"/>
+        <a:font script="Nkoo" typeface="Ebrima"/>
+        <a:font script="Olck" typeface="Nirmala UI"/>
+        <a:font script="Osma" typeface="Ebrima"/>
+        <a:font script="Phag" typeface="Phagspa"/>
+        <a:font script="Syrn" typeface="Estrangelo Edessa"/>
+        <a:font script="Syrj" typeface="Estrangelo Edessa"/>
+        <a:font script="Syre" typeface="Estrangelo Edessa"/>
+        <a:font script="Sora" typeface="Nirmala UI"/>
+        <a:font script="Tale" typeface="Microsoft Tai Le"/>
+        <a:font script="Talu" typeface="Microsoft New Tai Lue"/>
+        <a:font script="Tfng" typeface="Ebrima"/>
+      </a:minorFont>
+    </a:fontScheme>
+    <a:fmtScheme name="Office">
+      <a:fillStyleLst>
+        <a:solidFill>
+          <a:schemeClr val="phClr"/>
+        </a:solidFill>
+        <a:gradFill rotWithShape="1">
+          <a:gsLst>
+            <a:gs pos="0">
+              <a:schemeClr val="phClr">
+                <a:lumMod val="110000"/>
+                <a:satMod val="105000"/>
+                <a:tint val="67000"/>
+              </a:schemeClr>
+            </a:gs>
+            <a:gs pos="50000">
+              <a:schemeClr val="phClr">
+                <a:lumMod val="105000"/>
+                <a:satMod val="103000"/>
+                <a:tint val="73000"/>
+              </a:schemeClr>
+            </a:gs>
+            <a:gs pos="100000">
+              <a:schemeClr val="phClr">
+                <a:lumMod val="105000"/>
+                <a:satMod val="109000"/>
+                <a:tint val="81000"/>
+              </a:schemeClr>
+            </a:gs>
+          </a:gsLst>
+          <a:lin ang="5400000" scaled="0"/>
+        </a:gradFill>
+        <a:gradFill rotWithShape="1">
+          <a:gsLst>
+            <a:gs pos="0">
+              <a:schemeClr val="phClr">
+                <a:satMod val="103000"/>
+                <a:lumMod val="102000"/>
+                <a:tint val="94000"/>
+              </a:schemeClr>
+            </a:gs>
+            <a:gs pos="50000">
+              <a:schemeClr val="phClr">
+                <a:satMod val="110000"/>
+                <a:lumMod val="100000"/>
+                <a:shade val="100000"/>
+              </a:schemeClr>
+            </a:gs>
+            <a:gs pos="100000">
+              <a:schemeClr val="phClr">
+                <a:lumMod val="99000"/>
+                <a:satMod val="120000"/>
+                <a:shade val="78000"/>
+              </a:schemeClr>
+            </a:gs>
+          </a:gsLst>
+          <a:lin ang="5400000" scaled="0"/>
+        </a:gradFill>
+      </a:fillStyleLst>
+      <a:lnStyleLst>
+        <a:ln w="12700" cap="flat" cmpd="sng" algn="ctr">
+          <a:solidFill>
+            <a:schemeClr val="phClr"/>
+          </a:solidFill>
+          <a:prstDash val="solid"/>
+          <a:miter lim="800000"/>
+        </a:ln>
+        <a:ln w="19050" cap="flat" cmpd="sng" algn="ctr">
+          <a:solidFill>
+            <a:schemeClr val="phClr"/>
+          </a:solidFill>
+          <a:prstDash val="solid"/>
+          <a:miter lim="800000"/>
+        </a:ln>
+        <a:ln w="25400" cap="flat" cmpd="sng" algn="ctr">
+          <a:solidFill>
+            <a:schemeClr val="phClr"/>
+          </a:solidFill>
+          <a:prstDash val="solid"/>
+          <a:miter lim="800000"/>
+        </a:ln>
+      </a:lnStyleLst>
+      <a:effectStyleLst>
+        <a:effectStyle>
+          <a:effectLst/>
+        </a:effectStyle>
+        <a:effectStyle>
+          <a:effectLst/>
+        </a:effectStyle>
+        <a:effectStyle>
+          <a:effectLst>
+            <a:outerShdw blurRad="57150" dist="19050" dir="5400000" algn="ctr" rotWithShape="0">
+              <a:srgbClr val="000000">
+                <a:alpha val="63000"/>
+              </a:srgbClr>
+            </a:outerShdw>
+          </a:effectLst>
+        </a:effectStyle>
+      </a:effectStyleLst>
+      <a:bgFillStyleLst>
+        <a:solidFill>
+          <a:schemeClr val="phClr"/>
+        </a:solidFill>
+        <a:solidFill>
+          <a:schemeClr val="phClr">
+            <a:tint val="95000"/>
+            <a:satMod val="170000"/>
+          </a:schemeClr>
+        </a:solidFill>
+        <a:gradFill rotWithShape="1">
+          <a:gsLst>
+            <a:gs pos="0">
+              <a:schemeClr val="phClr">
+                <a:tint val="93000"/>
+                <a:satMod val="150000"/>
+                <a:shade val="98000"/>
+                <a:lumMod val="102000"/>
+              </a:schemeClr>
+            </a:gs>
+            <a:gs pos="50000">
+              <a:schemeClr val="phClr">
+                <a:tint val="98000"/>
+                <a:satMod val="130000"/>
+                <a:shade val="90000"/>
+                <a:lumMod val="103000"/>
+              </a:schemeClr>
+            </a:gs>
+            <a:gs pos="100000">
+              <a:schemeClr val="phClr">
+                <a:shade val="63000"/>
+                <a:satMod val="120000"/>
+              </a:schemeClr>
+            </a:gs>
+          </a:gsLst>
+          <a:lin ang="5400000" scaled="0"/>
+        </a:gradFill>
+      </a:bgFillStyleLst>
+    </a:fmtScheme>
+  </a:themeElements>
+  <a:objectDefaults>
+    <a:lnDef>
+      <a:spPr/>
+      <a:bodyPr/>
+      <a:lstStyle/>
+      <a:style>
+        <a:lnRef idx="2">
+          <a:schemeClr val="accent1"/>
+        </a:lnRef>
+        <a:fillRef idx="0">
+          <a:schemeClr val="accent1"/>
+        </a:fillRef>
+        <a:effectRef idx="1">
+          <a:schemeClr val="accent1"/>
+        </a:effectRef>
+        <a:fontRef idx="minor">
+          <a:schemeClr val="tx1"/>
+        </a:fontRef>
+      </a:style>
+    </a:lnDef>
+  </a:objectDefaults>
+  <a:extraClrSchemeLst/>
+  <a:extLst>
+    <a:ext uri="{05A4C25C-085E-4340-85A3-A5531E510DB2}">
+      <thm15:themeFamily xmlns:thm15="http://schemas.microsoft.com/office/thememl/2012/main" name="Office Theme" id="{2E142A2C-CD16-42D6-873A-C26D2A0506FA}" vid="{1BDDFF52-6CD6-40A5-AB3C-68EB2F1E4D0A}"/>
+    </a:ext>
+  </a:extLst>
+</a:theme>
 </file>
</xml_diff>